<commit_message>
fix(v7.1): enforce cross-platform zip determinism, sync slide 2 fraud wording, and align git html baselines
</commit_message>
<xml_diff>
--- a/ReturnLens_v7_1.pptx
+++ b/ReturnLens_v7_1.pptx
@@ -6570,11 +6570,11 @@
               </a:defRPr>
             </a:pPr>
             <a:r>
-              <a:t>• 9.0% — Return Fraud (NRF 2025): Strict criminal fraud only (unboxing swaps, empty boxes).</a:t>
+              <a:t>• 9.0% — Return Fraud (NRF 2025: criminal only): Strict criminal fraud (unboxing swaps, empty boxes).</a:t>
             </a:r>
             <a:br/>
             <a:r>
-              <a:t>• 15.14% — Fraud + Policy Abuse (Appriss/Deloitte 2024): Criminal fraud combined with policy abuse.</a:t>
+              <a:t>• 15.14% — Fraud + Policy Abuse (Appriss/Deloitte 2024: criminal + abuse): Criminal fraud combined with policy abuse (wardrobing).</a:t>
             </a:r>
           </a:p>
         </p:txBody>

</xml_diff>